<commit_message>
Replace stored procedure references with SSIS architecture in presentation
</commit_message>
<xml_diff>
--- a/docs/Final_Presentation.pptx
+++ b/docs/Final_Presentation.pptx
@@ -2975,6 +2975,10 @@
           </a:solidFill>
           <a:ln/>
         </p:spPr>
+        <p:txBody>
+          <a:bodyPr/>
+          <a:p/>
+        </p:txBody>
       </p:sp>
       <p:sp>
         <p:nvSpPr>
@@ -3070,6 +3074,10 @@
           </a:solidFill>
           <a:ln/>
         </p:spPr>
+        <p:txBody>
+          <a:bodyPr/>
+          <a:p/>
+        </p:txBody>
       </p:sp>
       <p:sp>
         <p:nvSpPr>
@@ -3097,6 +3105,10 @@
             </a:outerShdw>
           </a:effectLst>
         </p:spPr>
+        <p:txBody>
+          <a:bodyPr/>
+          <a:p/>
+        </p:txBody>
       </p:sp>
       <p:sp>
         <p:nvSpPr>
@@ -3117,6 +3129,10 @@
           </a:solidFill>
           <a:ln/>
         </p:spPr>
+        <p:txBody>
+          <a:bodyPr/>
+          <a:p/>
+        </p:txBody>
       </p:sp>
       <p:sp>
         <p:nvSpPr>
@@ -3255,6 +3271,10 @@
             </a:outerShdw>
           </a:effectLst>
         </p:spPr>
+        <p:txBody>
+          <a:bodyPr/>
+          <a:p/>
+        </p:txBody>
       </p:sp>
       <p:sp>
         <p:nvSpPr>
@@ -3275,6 +3295,10 @@
           </a:solidFill>
           <a:ln/>
         </p:spPr>
+        <p:txBody>
+          <a:bodyPr/>
+          <a:p/>
+        </p:txBody>
       </p:sp>
       <p:sp>
         <p:nvSpPr>
@@ -3413,6 +3437,10 @@
             </a:outerShdw>
           </a:effectLst>
         </p:spPr>
+        <p:txBody>
+          <a:bodyPr/>
+          <a:p/>
+        </p:txBody>
       </p:sp>
       <p:sp>
         <p:nvSpPr>
@@ -3433,6 +3461,10 @@
           </a:solidFill>
           <a:ln/>
         </p:spPr>
+        <p:txBody>
+          <a:bodyPr/>
+          <a:p/>
+        </p:txBody>
       </p:sp>
       <p:sp>
         <p:nvSpPr>
@@ -3539,7 +3571,7 @@
                   <a:srgbClr val="16A34A"/>
                 </a:solidFill>
               </a:rPr>
-              <a:t>After: ETL control: batch/step logs, per-step TRY-CATCH isolation</a:t>
+              <a:t>After: ETL control: batch/step logs, per-package OnError Event Handlers</a:t>
             </a:r>
             <a:endParaRPr lang="en-US" sz="900" dirty="0"/>
           </a:p>
@@ -3571,6 +3603,10 @@
             </a:outerShdw>
           </a:effectLst>
         </p:spPr>
+        <p:txBody>
+          <a:bodyPr/>
+          <a:p/>
+        </p:txBody>
       </p:sp>
       <p:sp>
         <p:nvSpPr>
@@ -3591,6 +3627,10 @@
           </a:solidFill>
           <a:ln/>
         </p:spPr>
+        <p:txBody>
+          <a:bodyPr/>
+          <a:p/>
+        </p:txBody>
       </p:sp>
       <p:sp>
         <p:nvSpPr>
@@ -3755,6 +3795,10 @@
           </a:solidFill>
           <a:ln/>
         </p:spPr>
+        <p:txBody>
+          <a:bodyPr/>
+          <a:p/>
+        </p:txBody>
       </p:sp>
       <p:sp>
         <p:nvSpPr>
@@ -3850,6 +3894,10 @@
           </a:solidFill>
           <a:ln/>
         </p:spPr>
+        <p:txBody>
+          <a:bodyPr/>
+          <a:p/>
+        </p:txBody>
       </p:sp>
       <p:graphicFrame>
         <p:nvGraphicFramePr>
@@ -5805,6 +5853,10 @@
           </a:solidFill>
           <a:ln/>
         </p:spPr>
+        <p:txBody>
+          <a:bodyPr/>
+          <a:p/>
+        </p:txBody>
       </p:sp>
       <p:sp>
         <p:nvSpPr>
@@ -5825,6 +5877,10 @@
           </a:solidFill>
           <a:ln/>
         </p:spPr>
+        <p:txBody>
+          <a:bodyPr/>
+          <a:p/>
+        </p:txBody>
       </p:sp>
       <p:sp>
         <p:nvSpPr>
@@ -6008,6 +6064,10 @@
           </a:solidFill>
           <a:ln/>
         </p:spPr>
+        <p:txBody>
+          <a:bodyPr/>
+          <a:p/>
+        </p:txBody>
       </p:sp>
       <p:sp>
         <p:nvSpPr>
@@ -6103,6 +6163,10 @@
           </a:solidFill>
           <a:ln/>
         </p:spPr>
+        <p:txBody>
+          <a:bodyPr/>
+          <a:p/>
+        </p:txBody>
       </p:sp>
       <p:graphicFrame>
         <p:nvGraphicFramePr>
@@ -7434,6 +7498,10 @@
           </a:solidFill>
           <a:ln/>
         </p:spPr>
+        <p:txBody>
+          <a:bodyPr/>
+          <a:p/>
+        </p:txBody>
       </p:sp>
       <p:sp>
         <p:nvSpPr>
@@ -7523,6 +7591,10 @@
           </a:solidFill>
           <a:ln/>
         </p:spPr>
+        <p:txBody>
+          <a:bodyPr/>
+          <a:p/>
+        </p:txBody>
       </p:sp>
       <p:sp>
         <p:nvSpPr>
@@ -7618,6 +7690,10 @@
           </a:solidFill>
           <a:ln/>
         </p:spPr>
+        <p:txBody>
+          <a:bodyPr/>
+          <a:p/>
+        </p:txBody>
       </p:sp>
       <p:graphicFrame>
         <p:nvGraphicFramePr>
@@ -9718,6 +9794,10 @@
           </a:solidFill>
           <a:ln/>
         </p:spPr>
+        <p:txBody>
+          <a:bodyPr/>
+          <a:p/>
+        </p:txBody>
       </p:sp>
       <p:sp>
         <p:nvSpPr>
@@ -9813,6 +9893,10 @@
           </a:solidFill>
           <a:ln/>
         </p:spPr>
+        <p:txBody>
+          <a:bodyPr/>
+          <a:p/>
+        </p:txBody>
       </p:sp>
       <p:sp>
         <p:nvSpPr>
@@ -9840,6 +9924,10 @@
             </a:outerShdw>
           </a:effectLst>
         </p:spPr>
+        <p:txBody>
+          <a:bodyPr/>
+          <a:p/>
+        </p:txBody>
       </p:sp>
       <p:sp>
         <p:nvSpPr>
@@ -9860,6 +9948,10 @@
           </a:solidFill>
           <a:ln/>
         </p:spPr>
+        <p:txBody>
+          <a:bodyPr/>
+          <a:p/>
+        </p:txBody>
       </p:sp>
       <p:sp>
         <p:nvSpPr>
@@ -10013,6 +10105,10 @@
           </a:solidFill>
           <a:ln/>
         </p:spPr>
+        <p:txBody>
+          <a:bodyPr/>
+          <a:p/>
+        </p:txBody>
       </p:sp>
       <p:sp>
         <p:nvSpPr>
@@ -10076,6 +10172,10 @@
             </a:outerShdw>
           </a:effectLst>
         </p:spPr>
+        <p:txBody>
+          <a:bodyPr/>
+          <a:p/>
+        </p:txBody>
       </p:sp>
       <p:sp>
         <p:nvSpPr>
@@ -10096,6 +10196,10 @@
           </a:solidFill>
           <a:ln/>
         </p:spPr>
+        <p:txBody>
+          <a:bodyPr/>
+          <a:p/>
+        </p:txBody>
       </p:sp>
       <p:sp>
         <p:nvSpPr>
@@ -10267,6 +10371,10 @@
           </a:solidFill>
           <a:ln/>
         </p:spPr>
+        <p:txBody>
+          <a:bodyPr/>
+          <a:p/>
+        </p:txBody>
       </p:sp>
       <p:sp>
         <p:nvSpPr>
@@ -10330,6 +10438,10 @@
             </a:outerShdw>
           </a:effectLst>
         </p:spPr>
+        <p:txBody>
+          <a:bodyPr/>
+          <a:p/>
+        </p:txBody>
       </p:sp>
       <p:sp>
         <p:nvSpPr>
@@ -10350,6 +10462,10 @@
           </a:solidFill>
           <a:ln/>
         </p:spPr>
+        <p:txBody>
+          <a:bodyPr/>
+          <a:p/>
+        </p:txBody>
       </p:sp>
       <p:sp>
         <p:nvSpPr>
@@ -10521,6 +10637,10 @@
           </a:solidFill>
           <a:ln/>
         </p:spPr>
+        <p:txBody>
+          <a:bodyPr/>
+          <a:p/>
+        </p:txBody>
       </p:sp>
       <p:sp>
         <p:nvSpPr>
@@ -10610,6 +10730,10 @@
           </a:solidFill>
           <a:ln/>
         </p:spPr>
+        <p:txBody>
+          <a:bodyPr/>
+          <a:p/>
+        </p:txBody>
       </p:sp>
       <p:sp>
         <p:nvSpPr>
@@ -10705,6 +10829,10 @@
           </a:solidFill>
           <a:ln/>
         </p:spPr>
+        <p:txBody>
+          <a:bodyPr/>
+          <a:p/>
+        </p:txBody>
       </p:sp>
       <p:sp>
         <p:nvSpPr>
@@ -10732,6 +10860,10 @@
             </a:outerShdw>
           </a:effectLst>
         </p:spPr>
+        <p:txBody>
+          <a:bodyPr/>
+          <a:p/>
+        </p:txBody>
       </p:sp>
       <p:sp>
         <p:nvSpPr>
@@ -10752,6 +10884,10 @@
           </a:solidFill>
           <a:ln/>
         </p:spPr>
+        <p:txBody>
+          <a:bodyPr/>
+          <a:p/>
+        </p:txBody>
       </p:sp>
       <p:sp>
         <p:nvSpPr>
@@ -10854,6 +10990,10 @@
             </a:outerShdw>
           </a:effectLst>
         </p:spPr>
+        <p:txBody>
+          <a:bodyPr/>
+          <a:p/>
+        </p:txBody>
       </p:sp>
       <p:sp>
         <p:nvSpPr>
@@ -10874,6 +11014,10 @@
           </a:solidFill>
           <a:ln/>
         </p:spPr>
+        <p:txBody>
+          <a:bodyPr/>
+          <a:p/>
+        </p:txBody>
       </p:sp>
       <p:sp>
         <p:nvSpPr>
@@ -10976,6 +11120,10 @@
             </a:outerShdw>
           </a:effectLst>
         </p:spPr>
+        <p:txBody>
+          <a:bodyPr/>
+          <a:p/>
+        </p:txBody>
       </p:sp>
       <p:sp>
         <p:nvSpPr>
@@ -10996,6 +11144,10 @@
           </a:solidFill>
           <a:ln/>
         </p:spPr>
+        <p:txBody>
+          <a:bodyPr/>
+          <a:p/>
+        </p:txBody>
       </p:sp>
       <p:sp>
         <p:nvSpPr>
@@ -11124,6 +11276,10 @@
           </a:solidFill>
           <a:ln/>
         </p:spPr>
+        <p:txBody>
+          <a:bodyPr/>
+          <a:p/>
+        </p:txBody>
       </p:sp>
       <p:sp>
         <p:nvSpPr>
@@ -11219,6 +11375,10 @@
           </a:solidFill>
           <a:ln/>
         </p:spPr>
+        <p:txBody>
+          <a:bodyPr/>
+          <a:p/>
+        </p:txBody>
       </p:sp>
       <p:sp>
         <p:nvSpPr>
@@ -11310,7 +11470,7 @@
                   <a:srgbClr val="1E293B"/>
                 </a:solidFill>
               </a:rPr>
-              <a:t>Complete 4-layer architecture: 65 objects, 15 stored procedures, 49 ETL steps across 5 databases</a:t>
+              <a:t>Complete 4-layer architecture: 65 objects, 49 SSIS packages, 49 ETL steps across 5 databases</a:t>
             </a:r>
             <a:endParaRPr lang="en-US" sz="1000" dirty="0"/>
           </a:p>
@@ -11668,6 +11828,10 @@
           </a:solidFill>
           <a:ln/>
         </p:spPr>
+        <p:txBody>
+          <a:bodyPr/>
+          <a:p/>
+        </p:txBody>
       </p:sp>
       <p:sp>
         <p:nvSpPr>
@@ -11763,6 +11927,10 @@
           </a:solidFill>
           <a:ln/>
         </p:spPr>
+        <p:txBody>
+          <a:bodyPr/>
+          <a:p/>
+        </p:txBody>
       </p:sp>
       <p:sp>
         <p:nvSpPr>
@@ -11790,6 +11958,10 @@
             </a:outerShdw>
           </a:effectLst>
         </p:spPr>
+        <p:txBody>
+          <a:bodyPr/>
+          <a:p/>
+        </p:txBody>
       </p:sp>
       <p:sp>
         <p:nvSpPr>
@@ -11810,6 +11982,10 @@
           </a:solidFill>
           <a:ln/>
         </p:spPr>
+        <p:txBody>
+          <a:bodyPr/>
+          <a:p/>
+        </p:txBody>
       </p:sp>
       <p:sp>
         <p:nvSpPr>
@@ -11873,6 +12049,10 @@
             </a:outerShdw>
           </a:effectLst>
         </p:spPr>
+        <p:txBody>
+          <a:bodyPr/>
+          <a:p/>
+        </p:txBody>
       </p:sp>
       <p:sp>
         <p:nvSpPr>
@@ -11893,6 +12073,10 @@
           </a:solidFill>
           <a:ln/>
         </p:spPr>
+        <p:txBody>
+          <a:bodyPr/>
+          <a:p/>
+        </p:txBody>
       </p:sp>
       <p:sp>
         <p:nvSpPr>
@@ -11956,6 +12140,10 @@
             </a:outerShdw>
           </a:effectLst>
         </p:spPr>
+        <p:txBody>
+          <a:bodyPr/>
+          <a:p/>
+        </p:txBody>
       </p:sp>
       <p:sp>
         <p:nvSpPr>
@@ -11976,6 +12164,10 @@
           </a:solidFill>
           <a:ln/>
         </p:spPr>
+        <p:txBody>
+          <a:bodyPr/>
+          <a:p/>
+        </p:txBody>
       </p:sp>
       <p:sp>
         <p:nvSpPr>
@@ -12039,6 +12231,10 @@
             </a:outerShdw>
           </a:effectLst>
         </p:spPr>
+        <p:txBody>
+          <a:bodyPr/>
+          <a:p/>
+        </p:txBody>
       </p:sp>
       <p:sp>
         <p:nvSpPr>
@@ -12059,6 +12255,10 @@
           </a:solidFill>
           <a:ln/>
         </p:spPr>
+        <p:txBody>
+          <a:bodyPr/>
+          <a:p/>
+        </p:txBody>
       </p:sp>
       <p:sp>
         <p:nvSpPr>
@@ -12122,6 +12322,10 @@
             </a:outerShdw>
           </a:effectLst>
         </p:spPr>
+        <p:txBody>
+          <a:bodyPr/>
+          <a:p/>
+        </p:txBody>
       </p:sp>
       <p:sp>
         <p:nvSpPr>
@@ -12142,6 +12346,10 @@
           </a:solidFill>
           <a:ln/>
         </p:spPr>
+        <p:txBody>
+          <a:bodyPr/>
+          <a:p/>
+        </p:txBody>
       </p:sp>
       <p:sp>
         <p:nvSpPr>
@@ -12205,6 +12413,10 @@
             </a:outerShdw>
           </a:effectLst>
         </p:spPr>
+        <p:txBody>
+          <a:bodyPr/>
+          <a:p/>
+        </p:txBody>
       </p:sp>
       <p:sp>
         <p:nvSpPr>
@@ -12225,6 +12437,10 @@
           </a:solidFill>
           <a:ln/>
         </p:spPr>
+        <p:txBody>
+          <a:bodyPr/>
+          <a:p/>
+        </p:txBody>
       </p:sp>
       <p:sp>
         <p:nvSpPr>
@@ -12314,6 +12530,10 @@
           </a:solidFill>
           <a:ln/>
         </p:spPr>
+        <p:txBody>
+          <a:bodyPr/>
+          <a:p/>
+        </p:txBody>
       </p:sp>
       <p:sp>
         <p:nvSpPr>
@@ -12334,6 +12554,10 @@
           </a:solidFill>
           <a:ln/>
         </p:spPr>
+        <p:txBody>
+          <a:bodyPr/>
+          <a:p/>
+        </p:txBody>
       </p:sp>
       <p:pic>
         <p:nvPicPr>
@@ -12417,6 +12641,10 @@
           </a:solidFill>
           <a:ln/>
         </p:spPr>
+        <p:txBody>
+          <a:bodyPr/>
+          <a:p/>
+        </p:txBody>
       </p:sp>
       <p:sp>
         <p:nvSpPr>
@@ -13639,6 +13867,10 @@
           </a:solidFill>
           <a:ln/>
         </p:spPr>
+        <p:txBody>
+          <a:bodyPr/>
+          <a:p/>
+        </p:txBody>
       </p:sp>
       <p:sp>
         <p:nvSpPr>
@@ -13734,6 +13966,10 @@
           </a:solidFill>
           <a:ln/>
         </p:spPr>
+        <p:txBody>
+          <a:bodyPr/>
+          <a:p/>
+        </p:txBody>
       </p:sp>
       <p:sp>
         <p:nvSpPr>
@@ -13761,6 +13997,10 @@
             </a:outerShdw>
           </a:effectLst>
         </p:spPr>
+        <p:txBody>
+          <a:bodyPr/>
+          <a:p/>
+        </p:txBody>
       </p:sp>
       <p:sp>
         <p:nvSpPr>
@@ -13781,6 +14021,10 @@
           </a:solidFill>
           <a:ln/>
         </p:spPr>
+        <p:txBody>
+          <a:bodyPr/>
+          <a:p/>
+        </p:txBody>
       </p:sp>
       <p:sp>
         <p:nvSpPr>
@@ -13959,6 +14203,10 @@
             </a:outerShdw>
           </a:effectLst>
         </p:spPr>
+        <p:txBody>
+          <a:bodyPr/>
+          <a:p/>
+        </p:txBody>
       </p:sp>
       <p:sp>
         <p:nvSpPr>
@@ -13979,6 +14227,10 @@
           </a:solidFill>
           <a:ln/>
         </p:spPr>
+        <p:txBody>
+          <a:bodyPr/>
+          <a:p/>
+        </p:txBody>
       </p:sp>
       <p:sp>
         <p:nvSpPr>
@@ -14152,6 +14404,10 @@
             </a:outerShdw>
           </a:effectLst>
         </p:spPr>
+        <p:txBody>
+          <a:bodyPr/>
+          <a:p/>
+        </p:txBody>
       </p:sp>
       <p:sp>
         <p:nvSpPr>
@@ -14172,6 +14428,10 @@
           </a:solidFill>
           <a:ln/>
         </p:spPr>
+        <p:txBody>
+          <a:bodyPr/>
+          <a:p/>
+        </p:txBody>
       </p:sp>
       <p:sp>
         <p:nvSpPr>
@@ -14388,6 +14648,10 @@
           </a:solidFill>
           <a:ln/>
         </p:spPr>
+        <p:txBody>
+          <a:bodyPr/>
+          <a:p/>
+        </p:txBody>
       </p:sp>
       <p:sp>
         <p:nvSpPr>
@@ -14483,6 +14747,10 @@
           </a:solidFill>
           <a:ln/>
         </p:spPr>
+        <p:txBody>
+          <a:bodyPr/>
+          <a:p/>
+        </p:txBody>
       </p:sp>
       <p:sp>
         <p:nvSpPr>
@@ -14510,6 +14778,10 @@
             </a:outerShdw>
           </a:effectLst>
         </p:spPr>
+        <p:txBody>
+          <a:bodyPr/>
+          <a:p/>
+        </p:txBody>
       </p:sp>
       <p:sp>
         <p:nvSpPr>
@@ -14530,6 +14802,10 @@
           </a:solidFill>
           <a:ln/>
         </p:spPr>
+        <p:txBody>
+          <a:bodyPr/>
+          <a:p/>
+        </p:txBody>
       </p:sp>
       <p:sp>
         <p:nvSpPr>
@@ -14919,6 +15195,10 @@
           </a:solidFill>
           <a:ln/>
         </p:spPr>
+        <p:txBody>
+          <a:bodyPr/>
+          <a:p/>
+        </p:txBody>
       </p:sp>
       <p:sp>
         <p:nvSpPr>
@@ -15014,6 +15294,10 @@
           </a:solidFill>
           <a:ln/>
         </p:spPr>
+        <p:txBody>
+          <a:bodyPr/>
+          <a:p/>
+        </p:txBody>
       </p:sp>
       <p:sp>
         <p:nvSpPr>
@@ -15041,6 +15325,10 @@
             </a:outerShdw>
           </a:effectLst>
         </p:spPr>
+        <p:txBody>
+          <a:bodyPr/>
+          <a:p/>
+        </p:txBody>
       </p:sp>
       <p:sp>
         <p:nvSpPr>
@@ -15061,6 +15349,10 @@
           </a:solidFill>
           <a:ln/>
         </p:spPr>
+        <p:txBody>
+          <a:bodyPr/>
+          <a:p/>
+        </p:txBody>
       </p:sp>
       <p:sp>
         <p:nvSpPr>
@@ -15221,6 +15513,10 @@
             </a:outerShdw>
           </a:effectLst>
         </p:spPr>
+        <p:txBody>
+          <a:bodyPr/>
+          <a:p/>
+        </p:txBody>
       </p:sp>
       <p:sp>
         <p:nvSpPr>
@@ -15241,6 +15537,10 @@
           </a:solidFill>
           <a:ln/>
         </p:spPr>
+        <p:txBody>
+          <a:bodyPr/>
+          <a:p/>
+        </p:txBody>
       </p:sp>
       <p:sp>
         <p:nvSpPr>
@@ -15401,6 +15701,10 @@
             </a:outerShdw>
           </a:effectLst>
         </p:spPr>
+        <p:txBody>
+          <a:bodyPr/>
+          <a:p/>
+        </p:txBody>
       </p:sp>
       <p:sp>
         <p:nvSpPr>
@@ -15421,6 +15725,10 @@
           </a:solidFill>
           <a:ln/>
         </p:spPr>
+        <p:txBody>
+          <a:bodyPr/>
+          <a:p/>
+        </p:txBody>
       </p:sp>
       <p:sp>
         <p:nvSpPr>
@@ -15604,6 +15912,10 @@
           </a:solidFill>
           <a:ln/>
         </p:spPr>
+        <p:txBody>
+          <a:bodyPr/>
+          <a:p/>
+        </p:txBody>
       </p:sp>
       <p:sp>
         <p:nvSpPr>
@@ -15699,6 +16011,10 @@
           </a:solidFill>
           <a:ln/>
         </p:spPr>
+        <p:txBody>
+          <a:bodyPr/>
+          <a:p/>
+        </p:txBody>
       </p:sp>
       <p:graphicFrame>
         <p:nvGraphicFramePr>
@@ -17911,6 +18227,10 @@
           </a:solidFill>
           <a:ln/>
         </p:spPr>
+        <p:txBody>
+          <a:bodyPr/>
+          <a:p/>
+        </p:txBody>
       </p:sp>
       <p:sp>
         <p:nvSpPr>
@@ -18006,6 +18326,10 @@
           </a:solidFill>
           <a:ln/>
         </p:spPr>
+        <p:txBody>
+          <a:bodyPr/>
+          <a:p/>
+        </p:txBody>
       </p:sp>
       <p:sp>
         <p:nvSpPr>
@@ -18033,6 +18357,10 @@
             </a:outerShdw>
           </a:effectLst>
         </p:spPr>
+        <p:txBody>
+          <a:bodyPr/>
+          <a:p/>
+        </p:txBody>
       </p:sp>
       <p:sp>
         <p:nvSpPr>
@@ -18053,6 +18381,10 @@
           </a:solidFill>
           <a:ln/>
         </p:spPr>
+        <p:txBody>
+          <a:bodyPr/>
+          <a:p/>
+        </p:txBody>
       </p:sp>
       <p:sp>
         <p:nvSpPr>
@@ -18202,6 +18534,10 @@
             </a:outerShdw>
           </a:effectLst>
         </p:spPr>
+        <p:txBody>
+          <a:bodyPr/>
+          <a:p/>
+        </p:txBody>
       </p:sp>
       <p:sp>
         <p:nvSpPr>
@@ -18222,6 +18558,10 @@
           </a:solidFill>
           <a:ln/>
         </p:spPr>
+        <p:txBody>
+          <a:bodyPr/>
+          <a:p/>
+        </p:txBody>
       </p:sp>
       <p:sp>
         <p:nvSpPr>
@@ -18371,6 +18711,10 @@
             </a:outerShdw>
           </a:effectLst>
         </p:spPr>
+        <p:txBody>
+          <a:bodyPr/>
+          <a:p/>
+        </p:txBody>
       </p:sp>
       <p:sp>
         <p:nvSpPr>
@@ -18391,6 +18735,10 @@
           </a:solidFill>
           <a:ln/>
         </p:spPr>
+        <p:txBody>
+          <a:bodyPr/>
+          <a:p/>
+        </p:txBody>
       </p:sp>
       <p:sp>
         <p:nvSpPr>
@@ -18554,6 +18902,10 @@
             </a:outerShdw>
           </a:effectLst>
         </p:spPr>
+        <p:txBody>
+          <a:bodyPr/>
+          <a:p/>
+        </p:txBody>
       </p:sp>
       <p:sp>
         <p:nvSpPr>
@@ -18574,6 +18926,10 @@
           </a:solidFill>
           <a:ln/>
         </p:spPr>
+        <p:txBody>
+          <a:bodyPr/>
+          <a:p/>
+        </p:txBody>
       </p:sp>
       <p:sp>
         <p:nvSpPr>
@@ -18737,6 +19093,10 @@
             </a:outerShdw>
           </a:effectLst>
         </p:spPr>
+        <p:txBody>
+          <a:bodyPr/>
+          <a:p/>
+        </p:txBody>
       </p:sp>
       <p:sp>
         <p:nvSpPr>
@@ -18757,6 +19117,10 @@
           </a:solidFill>
           <a:ln/>
         </p:spPr>
+        <p:txBody>
+          <a:bodyPr/>
+          <a:p/>
+        </p:txBody>
       </p:sp>
       <p:sp>
         <p:nvSpPr>
@@ -19050,6 +19414,10 @@
             </a:outerShdw>
           </a:effectLst>
         </p:spPr>
+        <p:txBody>
+          <a:bodyPr/>
+          <a:p/>
+        </p:txBody>
       </p:sp>
       <p:sp>
         <p:nvSpPr>
@@ -19070,6 +19438,10 @@
           </a:solidFill>
           <a:ln/>
         </p:spPr>
+        <p:txBody>
+          <a:bodyPr/>
+          <a:p/>
+        </p:txBody>
       </p:sp>
       <p:sp>
         <p:nvSpPr>
@@ -19213,7 +19585,7 @@
                   <a:srgbClr val="2A9D8F"/>
                 </a:solidFill>
               </a:rPr>
-              <a:t>Master: usp_MasterETL_FullLoad_Complete</a:t>
+              <a:t>Master: Master_Complete_Pipeline.dtsx</a:t>
             </a:r>
             <a:endParaRPr lang="en-US" sz="900" dirty="0"/>
           </a:p>
@@ -19245,6 +19617,10 @@
             </a:outerShdw>
           </a:effectLst>
         </p:spPr>
+        <p:txBody>
+          <a:bodyPr/>
+          <a:p/>
+        </p:txBody>
       </p:sp>
       <p:sp>
         <p:nvSpPr>
@@ -19265,6 +19641,10 @@
           </a:solidFill>
           <a:ln/>
         </p:spPr>
+        <p:txBody>
+          <a:bodyPr/>
+          <a:p/>
+        </p:txBody>
       </p:sp>
       <p:sp>
         <p:nvSpPr>
@@ -19466,6 +19846,10 @@
           </a:solidFill>
           <a:ln/>
         </p:spPr>
+        <p:txBody>
+          <a:bodyPr/>
+          <a:p/>
+        </p:txBody>
       </p:sp>
       <p:sp>
         <p:nvSpPr>
@@ -19561,6 +19945,10 @@
           </a:solidFill>
           <a:ln/>
         </p:spPr>
+        <p:txBody>
+          <a:bodyPr/>
+          <a:p/>
+        </p:txBody>
       </p:sp>
       <p:sp>
         <p:nvSpPr>
@@ -19588,6 +19976,10 @@
             </a:outerShdw>
           </a:effectLst>
         </p:spPr>
+        <p:txBody>
+          <a:bodyPr/>
+          <a:p/>
+        </p:txBody>
       </p:sp>
       <p:sp>
         <p:nvSpPr>
@@ -19608,6 +20000,10 @@
           </a:solidFill>
           <a:ln/>
         </p:spPr>
+        <p:txBody>
+          <a:bodyPr/>
+          <a:p/>
+        </p:txBody>
       </p:sp>
       <p:sp>
         <p:nvSpPr>
@@ -19747,6 +20143,10 @@
             </a:outerShdw>
           </a:effectLst>
         </p:spPr>
+        <p:txBody>
+          <a:bodyPr/>
+          <a:p/>
+        </p:txBody>
       </p:sp>
       <p:sp>
         <p:nvSpPr>
@@ -19767,6 +20167,10 @@
           </a:solidFill>
           <a:ln/>
         </p:spPr>
+        <p:txBody>
+          <a:bodyPr/>
+          <a:p/>
+        </p:txBody>
       </p:sp>
       <p:sp>
         <p:nvSpPr>
@@ -19924,6 +20328,10 @@
             </a:outerShdw>
           </a:effectLst>
         </p:spPr>
+        <p:txBody>
+          <a:bodyPr/>
+          <a:p/>
+        </p:txBody>
       </p:sp>
       <p:sp>
         <p:nvSpPr>
@@ -19944,6 +20352,10 @@
           </a:solidFill>
           <a:ln/>
         </p:spPr>
+        <p:txBody>
+          <a:bodyPr/>
+          <a:p/>
+        </p:txBody>
       </p:sp>
       <p:sp>
         <p:nvSpPr>
@@ -20083,6 +20495,10 @@
             </a:outerShdw>
           </a:effectLst>
         </p:spPr>
+        <p:txBody>
+          <a:bodyPr/>
+          <a:p/>
+        </p:txBody>
       </p:sp>
       <p:sp>
         <p:nvSpPr>
@@ -20103,6 +20519,10 @@
           </a:solidFill>
           <a:ln/>
         </p:spPr>
+        <p:txBody>
+          <a:bodyPr/>
+          <a:p/>
+        </p:txBody>
       </p:sp>
       <p:sp>
         <p:nvSpPr>
@@ -20260,6 +20680,10 @@
             </a:outerShdw>
           </a:effectLst>
         </p:spPr>
+        <p:txBody>
+          <a:bodyPr/>
+          <a:p/>
+        </p:txBody>
       </p:sp>
       <p:sp>
         <p:nvSpPr>
@@ -20280,6 +20704,10 @@
           </a:solidFill>
           <a:ln/>
         </p:spPr>
+        <p:txBody>
+          <a:bodyPr/>
+          <a:p/>
+        </p:txBody>
       </p:sp>
       <p:sp>
         <p:nvSpPr>
@@ -20343,6 +20771,10 @@
             </a:outerShdw>
           </a:effectLst>
         </p:spPr>
+        <p:txBody>
+          <a:bodyPr/>
+          <a:p/>
+        </p:txBody>
       </p:sp>
       <p:sp>
         <p:nvSpPr>
@@ -20456,6 +20888,10 @@
             </a:outerShdw>
           </a:effectLst>
         </p:spPr>
+        <p:txBody>
+          <a:bodyPr/>
+          <a:p/>
+        </p:txBody>
       </p:sp>
       <p:sp>
         <p:nvSpPr>
@@ -20569,6 +21005,10 @@
             </a:outerShdw>
           </a:effectLst>
         </p:spPr>
+        <p:txBody>
+          <a:bodyPr/>
+          <a:p/>
+        </p:txBody>
       </p:sp>
       <p:sp>
         <p:nvSpPr>
@@ -20682,6 +21122,10 @@
             </a:outerShdw>
           </a:effectLst>
         </p:spPr>
+        <p:txBody>
+          <a:bodyPr/>
+          <a:p/>
+        </p:txBody>
       </p:sp>
       <p:sp>
         <p:nvSpPr>
@@ -20795,6 +21239,10 @@
             </a:outerShdw>
           </a:effectLst>
         </p:spPr>
+        <p:txBody>
+          <a:bodyPr/>
+          <a:p/>
+        </p:txBody>
       </p:sp>
       <p:sp>
         <p:nvSpPr>
@@ -20908,6 +21356,10 @@
             </a:outerShdw>
           </a:effectLst>
         </p:spPr>
+        <p:txBody>
+          <a:bodyPr/>
+          <a:p/>
+        </p:txBody>
       </p:sp>
       <p:sp>
         <p:nvSpPr>
@@ -21021,6 +21473,10 @@
             </a:outerShdw>
           </a:effectLst>
         </p:spPr>
+        <p:txBody>
+          <a:bodyPr/>
+          <a:p/>
+        </p:txBody>
       </p:sp>
       <p:sp>
         <p:nvSpPr>
@@ -21134,6 +21590,10 @@
             </a:outerShdw>
           </a:effectLst>
         </p:spPr>
+        <p:txBody>
+          <a:bodyPr/>
+          <a:p/>
+        </p:txBody>
       </p:sp>
       <p:sp>
         <p:nvSpPr>
@@ -21237,6 +21697,10 @@
           </a:solidFill>
           <a:ln/>
         </p:spPr>
+        <p:txBody>
+          <a:bodyPr/>
+          <a:p/>
+        </p:txBody>
       </p:sp>
       <p:sp>
         <p:nvSpPr>
@@ -21332,6 +21796,10 @@
           </a:solidFill>
           <a:ln/>
         </p:spPr>
+        <p:txBody>
+          <a:bodyPr/>
+          <a:p/>
+        </p:txBody>
       </p:sp>
       <p:sp>
         <p:nvSpPr>

</xml_diff>